<commit_message>
Updated presentation slides and added an optional checkerboard pattern and persistence of settings
The options menu now includes a checkerboard option that will add a checkerboard patter the the game screen if chosen. When options are set in the options menu they will now persist after closing and reopening the program just like the high score.
Updated presentation slides and fixed various small details within the code.
</commit_message>
<xml_diff>
--- a/CS3080_Project_Presentation.pptx
+++ b/CS3080_Project_Presentation.pptx
@@ -4,6 +4,9 @@
   <p:sldMasterIdLst>
     <p:sldMasterId id="2147483648" r:id="rId1"/>
   </p:sldMasterIdLst>
+  <p:notesMasterIdLst>
+    <p:notesMasterId r:id="rId10"/>
+  </p:notesMasterIdLst>
   <p:sldIdLst>
     <p:sldId id="256" r:id="rId2"/>
     <p:sldId id="257" r:id="rId3"/>
@@ -11,6 +14,8 @@
     <p:sldId id="261" r:id="rId5"/>
     <p:sldId id="259" r:id="rId6"/>
     <p:sldId id="260" r:id="rId7"/>
+    <p:sldId id="262" r:id="rId8"/>
+    <p:sldId id="263" r:id="rId9"/>
   </p:sldIdLst>
   <p:sldSz cx="12192000" cy="6858000"/>
   <p:notesSz cx="6858000" cy="9144000"/>
@@ -117,6 +122,523 @@
 </p:presentation>
 </file>
 
+<file path=ppt/notesMasters/notesMaster1.xml><?xml version="1.0" encoding="utf-8"?>
+<p:notesMaster xmlns:a="http://schemas.openxmlformats.org/drawingml/2006/main" xmlns:r="http://schemas.openxmlformats.org/officeDocument/2006/relationships" xmlns:p="http://schemas.openxmlformats.org/presentationml/2006/main">
+  <p:cSld>
+    <p:bg>
+      <p:bgRef idx="1001">
+        <a:schemeClr val="bg1"/>
+      </p:bgRef>
+    </p:bg>
+    <p:spTree>
+      <p:nvGrpSpPr>
+        <p:cNvPr id="1" name=""/>
+        <p:cNvGrpSpPr/>
+        <p:nvPr/>
+      </p:nvGrpSpPr>
+      <p:grpSpPr>
+        <a:xfrm>
+          <a:off x="0" y="0"/>
+          <a:ext cx="0" cy="0"/>
+          <a:chOff x="0" y="0"/>
+          <a:chExt cx="0" cy="0"/>
+        </a:xfrm>
+      </p:grpSpPr>
+      <p:sp>
+        <p:nvSpPr>
+          <p:cNvPr id="2" name="Header Placeholder 1"/>
+          <p:cNvSpPr>
+            <a:spLocks noGrp="1"/>
+          </p:cNvSpPr>
+          <p:nvPr>
+            <p:ph type="hdr" sz="quarter"/>
+          </p:nvPr>
+        </p:nvSpPr>
+        <p:spPr>
+          <a:xfrm>
+            <a:off x="0" y="0"/>
+            <a:ext cx="2971800" cy="458788"/>
+          </a:xfrm>
+          <a:prstGeom prst="rect">
+            <a:avLst/>
+          </a:prstGeom>
+        </p:spPr>
+        <p:txBody>
+          <a:bodyPr vert="horz" lIns="91440" tIns="45720" rIns="91440" bIns="45720" rtlCol="0"/>
+          <a:lstStyle>
+            <a:lvl1pPr algn="l">
+              <a:defRPr sz="1200"/>
+            </a:lvl1pPr>
+          </a:lstStyle>
+          <a:p>
+            <a:endParaRPr lang="en-US"/>
+          </a:p>
+        </p:txBody>
+      </p:sp>
+      <p:sp>
+        <p:nvSpPr>
+          <p:cNvPr id="3" name="Date Placeholder 2"/>
+          <p:cNvSpPr>
+            <a:spLocks noGrp="1"/>
+          </p:cNvSpPr>
+          <p:nvPr>
+            <p:ph type="dt" idx="1"/>
+          </p:nvPr>
+        </p:nvSpPr>
+        <p:spPr>
+          <a:xfrm>
+            <a:off x="3884613" y="0"/>
+            <a:ext cx="2971800" cy="458788"/>
+          </a:xfrm>
+          <a:prstGeom prst="rect">
+            <a:avLst/>
+          </a:prstGeom>
+        </p:spPr>
+        <p:txBody>
+          <a:bodyPr vert="horz" lIns="91440" tIns="45720" rIns="91440" bIns="45720" rtlCol="0"/>
+          <a:lstStyle>
+            <a:lvl1pPr algn="r">
+              <a:defRPr sz="1200"/>
+            </a:lvl1pPr>
+          </a:lstStyle>
+          <a:p>
+            <a:fld id="{E9013859-9FC8-4602-8B22-1BA57C4A7C95}" type="datetimeFigureOut">
+              <a:rPr lang="en-US" smtClean="0"/>
+              <a:t>5/5/2026</a:t>
+            </a:fld>
+            <a:endParaRPr lang="en-US"/>
+          </a:p>
+        </p:txBody>
+      </p:sp>
+      <p:sp>
+        <p:nvSpPr>
+          <p:cNvPr id="4" name="Slide Image Placeholder 3"/>
+          <p:cNvSpPr>
+            <a:spLocks noGrp="1" noRot="1" noChangeAspect="1"/>
+          </p:cNvSpPr>
+          <p:nvPr>
+            <p:ph type="sldImg" idx="2"/>
+          </p:nvPr>
+        </p:nvSpPr>
+        <p:spPr>
+          <a:xfrm>
+            <a:off x="685800" y="1143000"/>
+            <a:ext cx="5486400" cy="3086100"/>
+          </a:xfrm>
+          <a:prstGeom prst="rect">
+            <a:avLst/>
+          </a:prstGeom>
+          <a:noFill/>
+          <a:ln w="12700">
+            <a:solidFill>
+              <a:prstClr val="black"/>
+            </a:solidFill>
+          </a:ln>
+        </p:spPr>
+        <p:txBody>
+          <a:bodyPr vert="horz" lIns="91440" tIns="45720" rIns="91440" bIns="45720" rtlCol="0" anchor="ctr"/>
+          <a:lstStyle/>
+          <a:p>
+            <a:endParaRPr lang="en-US"/>
+          </a:p>
+        </p:txBody>
+      </p:sp>
+      <p:sp>
+        <p:nvSpPr>
+          <p:cNvPr id="5" name="Notes Placeholder 4"/>
+          <p:cNvSpPr>
+            <a:spLocks noGrp="1"/>
+          </p:cNvSpPr>
+          <p:nvPr>
+            <p:ph type="body" sz="quarter" idx="3"/>
+          </p:nvPr>
+        </p:nvSpPr>
+        <p:spPr>
+          <a:xfrm>
+            <a:off x="685800" y="4400550"/>
+            <a:ext cx="5486400" cy="3600450"/>
+          </a:xfrm>
+          <a:prstGeom prst="rect">
+            <a:avLst/>
+          </a:prstGeom>
+        </p:spPr>
+        <p:txBody>
+          <a:bodyPr vert="horz" lIns="91440" tIns="45720" rIns="91440" bIns="45720" rtlCol="0"/>
+          <a:lstStyle/>
+          <a:p>
+            <a:pPr lvl="0"/>
+            <a:r>
+              <a:rPr lang="en-US"/>
+              <a:t>Click to edit Master text styles</a:t>
+            </a:r>
+          </a:p>
+          <a:p>
+            <a:pPr lvl="1"/>
+            <a:r>
+              <a:rPr lang="en-US"/>
+              <a:t>Second level</a:t>
+            </a:r>
+          </a:p>
+          <a:p>
+            <a:pPr lvl="2"/>
+            <a:r>
+              <a:rPr lang="en-US"/>
+              <a:t>Third level</a:t>
+            </a:r>
+          </a:p>
+          <a:p>
+            <a:pPr lvl="3"/>
+            <a:r>
+              <a:rPr lang="en-US"/>
+              <a:t>Fourth level</a:t>
+            </a:r>
+          </a:p>
+          <a:p>
+            <a:pPr lvl="4"/>
+            <a:r>
+              <a:rPr lang="en-US"/>
+              <a:t>Fifth level</a:t>
+            </a:r>
+          </a:p>
+        </p:txBody>
+      </p:sp>
+      <p:sp>
+        <p:nvSpPr>
+          <p:cNvPr id="6" name="Footer Placeholder 5"/>
+          <p:cNvSpPr>
+            <a:spLocks noGrp="1"/>
+          </p:cNvSpPr>
+          <p:nvPr>
+            <p:ph type="ftr" sz="quarter" idx="4"/>
+          </p:nvPr>
+        </p:nvSpPr>
+        <p:spPr>
+          <a:xfrm>
+            <a:off x="0" y="8685213"/>
+            <a:ext cx="2971800" cy="458787"/>
+          </a:xfrm>
+          <a:prstGeom prst="rect">
+            <a:avLst/>
+          </a:prstGeom>
+        </p:spPr>
+        <p:txBody>
+          <a:bodyPr vert="horz" lIns="91440" tIns="45720" rIns="91440" bIns="45720" rtlCol="0" anchor="b"/>
+          <a:lstStyle>
+            <a:lvl1pPr algn="l">
+              <a:defRPr sz="1200"/>
+            </a:lvl1pPr>
+          </a:lstStyle>
+          <a:p>
+            <a:endParaRPr lang="en-US"/>
+          </a:p>
+        </p:txBody>
+      </p:sp>
+      <p:sp>
+        <p:nvSpPr>
+          <p:cNvPr id="7" name="Slide Number Placeholder 6"/>
+          <p:cNvSpPr>
+            <a:spLocks noGrp="1"/>
+          </p:cNvSpPr>
+          <p:nvPr>
+            <p:ph type="sldNum" sz="quarter" idx="5"/>
+          </p:nvPr>
+        </p:nvSpPr>
+        <p:spPr>
+          <a:xfrm>
+            <a:off x="3884613" y="8685213"/>
+            <a:ext cx="2971800" cy="458787"/>
+          </a:xfrm>
+          <a:prstGeom prst="rect">
+            <a:avLst/>
+          </a:prstGeom>
+        </p:spPr>
+        <p:txBody>
+          <a:bodyPr vert="horz" lIns="91440" tIns="45720" rIns="91440" bIns="45720" rtlCol="0" anchor="b"/>
+          <a:lstStyle>
+            <a:lvl1pPr algn="r">
+              <a:defRPr sz="1200"/>
+            </a:lvl1pPr>
+          </a:lstStyle>
+          <a:p>
+            <a:fld id="{ECB4FCA9-8494-4F56-8FA5-838D269428B5}" type="slidenum">
+              <a:rPr lang="en-US" smtClean="0"/>
+              <a:t>‹#›</a:t>
+            </a:fld>
+            <a:endParaRPr lang="en-US"/>
+          </a:p>
+        </p:txBody>
+      </p:sp>
+    </p:spTree>
+    <p:extLst>
+      <p:ext uri="{BB962C8B-B14F-4D97-AF65-F5344CB8AC3E}">
+        <p14:creationId xmlns:p14="http://schemas.microsoft.com/office/powerpoint/2010/main" val="3044203860"/>
+      </p:ext>
+    </p:extLst>
+  </p:cSld>
+  <p:clrMap bg1="lt1" tx1="dk1" bg2="lt2" tx2="dk2" accent1="accent1" accent2="accent2" accent3="accent3" accent4="accent4" accent5="accent5" accent6="accent6" hlink="hlink" folHlink="folHlink"/>
+  <p:notesStyle>
+    <a:lvl1pPr marL="0" algn="l" defTabSz="914400" rtl="0" eaLnBrk="1" latinLnBrk="0" hangingPunct="1">
+      <a:defRPr sz="1200" kern="1200">
+        <a:solidFill>
+          <a:schemeClr val="tx1"/>
+        </a:solidFill>
+        <a:latin typeface="+mn-lt"/>
+        <a:ea typeface="+mn-ea"/>
+        <a:cs typeface="+mn-cs"/>
+      </a:defRPr>
+    </a:lvl1pPr>
+    <a:lvl2pPr marL="457200" algn="l" defTabSz="914400" rtl="0" eaLnBrk="1" latinLnBrk="0" hangingPunct="1">
+      <a:defRPr sz="1200" kern="1200">
+        <a:solidFill>
+          <a:schemeClr val="tx1"/>
+        </a:solidFill>
+        <a:latin typeface="+mn-lt"/>
+        <a:ea typeface="+mn-ea"/>
+        <a:cs typeface="+mn-cs"/>
+      </a:defRPr>
+    </a:lvl2pPr>
+    <a:lvl3pPr marL="914400" algn="l" defTabSz="914400" rtl="0" eaLnBrk="1" latinLnBrk="0" hangingPunct="1">
+      <a:defRPr sz="1200" kern="1200">
+        <a:solidFill>
+          <a:schemeClr val="tx1"/>
+        </a:solidFill>
+        <a:latin typeface="+mn-lt"/>
+        <a:ea typeface="+mn-ea"/>
+        <a:cs typeface="+mn-cs"/>
+      </a:defRPr>
+    </a:lvl3pPr>
+    <a:lvl4pPr marL="1371600" algn="l" defTabSz="914400" rtl="0" eaLnBrk="1" latinLnBrk="0" hangingPunct="1">
+      <a:defRPr sz="1200" kern="1200">
+        <a:solidFill>
+          <a:schemeClr val="tx1"/>
+        </a:solidFill>
+        <a:latin typeface="+mn-lt"/>
+        <a:ea typeface="+mn-ea"/>
+        <a:cs typeface="+mn-cs"/>
+      </a:defRPr>
+    </a:lvl4pPr>
+    <a:lvl5pPr marL="1828800" algn="l" defTabSz="914400" rtl="0" eaLnBrk="1" latinLnBrk="0" hangingPunct="1">
+      <a:defRPr sz="1200" kern="1200">
+        <a:solidFill>
+          <a:schemeClr val="tx1"/>
+        </a:solidFill>
+        <a:latin typeface="+mn-lt"/>
+        <a:ea typeface="+mn-ea"/>
+        <a:cs typeface="+mn-cs"/>
+      </a:defRPr>
+    </a:lvl5pPr>
+    <a:lvl6pPr marL="2286000" algn="l" defTabSz="914400" rtl="0" eaLnBrk="1" latinLnBrk="0" hangingPunct="1">
+      <a:defRPr sz="1200" kern="1200">
+        <a:solidFill>
+          <a:schemeClr val="tx1"/>
+        </a:solidFill>
+        <a:latin typeface="+mn-lt"/>
+        <a:ea typeface="+mn-ea"/>
+        <a:cs typeface="+mn-cs"/>
+      </a:defRPr>
+    </a:lvl6pPr>
+    <a:lvl7pPr marL="2743200" algn="l" defTabSz="914400" rtl="0" eaLnBrk="1" latinLnBrk="0" hangingPunct="1">
+      <a:defRPr sz="1200" kern="1200">
+        <a:solidFill>
+          <a:schemeClr val="tx1"/>
+        </a:solidFill>
+        <a:latin typeface="+mn-lt"/>
+        <a:ea typeface="+mn-ea"/>
+        <a:cs typeface="+mn-cs"/>
+      </a:defRPr>
+    </a:lvl7pPr>
+    <a:lvl8pPr marL="3200400" algn="l" defTabSz="914400" rtl="0" eaLnBrk="1" latinLnBrk="0" hangingPunct="1">
+      <a:defRPr sz="1200" kern="1200">
+        <a:solidFill>
+          <a:schemeClr val="tx1"/>
+        </a:solidFill>
+        <a:latin typeface="+mn-lt"/>
+        <a:ea typeface="+mn-ea"/>
+        <a:cs typeface="+mn-cs"/>
+      </a:defRPr>
+    </a:lvl8pPr>
+    <a:lvl9pPr marL="3657600" algn="l" defTabSz="914400" rtl="0" eaLnBrk="1" latinLnBrk="0" hangingPunct="1">
+      <a:defRPr sz="1200" kern="1200">
+        <a:solidFill>
+          <a:schemeClr val="tx1"/>
+        </a:solidFill>
+        <a:latin typeface="+mn-lt"/>
+        <a:ea typeface="+mn-ea"/>
+        <a:cs typeface="+mn-cs"/>
+      </a:defRPr>
+    </a:lvl9pPr>
+  </p:notesStyle>
+</p:notesMaster>
+</file>
+
+<file path=ppt/notesSlides/notesSlide1.xml><?xml version="1.0" encoding="utf-8"?>
+<p:notes xmlns:a="http://schemas.openxmlformats.org/drawingml/2006/main" xmlns:r="http://schemas.openxmlformats.org/officeDocument/2006/relationships" xmlns:p="http://schemas.openxmlformats.org/presentationml/2006/main">
+  <p:cSld>
+    <p:spTree>
+      <p:nvGrpSpPr>
+        <p:cNvPr id="1" name=""/>
+        <p:cNvGrpSpPr/>
+        <p:nvPr/>
+      </p:nvGrpSpPr>
+      <p:grpSpPr>
+        <a:xfrm>
+          <a:off x="0" y="0"/>
+          <a:ext cx="0" cy="0"/>
+          <a:chOff x="0" y="0"/>
+          <a:chExt cx="0" cy="0"/>
+        </a:xfrm>
+      </p:grpSpPr>
+      <p:sp>
+        <p:nvSpPr>
+          <p:cNvPr id="2" name="Slide Image Placeholder 1"/>
+          <p:cNvSpPr>
+            <a:spLocks noGrp="1" noRot="1" noChangeAspect="1"/>
+          </p:cNvSpPr>
+          <p:nvPr>
+            <p:ph type="sldImg"/>
+          </p:nvPr>
+        </p:nvSpPr>
+        <p:spPr/>
+      </p:sp>
+      <p:sp>
+        <p:nvSpPr>
+          <p:cNvPr id="3" name="Notes Placeholder 2"/>
+          <p:cNvSpPr>
+            <a:spLocks noGrp="1"/>
+          </p:cNvSpPr>
+          <p:nvPr>
+            <p:ph type="body" idx="1"/>
+          </p:nvPr>
+        </p:nvSpPr>
+        <p:spPr/>
+        <p:txBody>
+          <a:bodyPr/>
+          <a:lstStyle/>
+          <a:p>
+            <a:endParaRPr lang="en-US" dirty="0"/>
+          </a:p>
+        </p:txBody>
+      </p:sp>
+      <p:sp>
+        <p:nvSpPr>
+          <p:cNvPr id="4" name="Slide Number Placeholder 3"/>
+          <p:cNvSpPr>
+            <a:spLocks noGrp="1"/>
+          </p:cNvSpPr>
+          <p:nvPr>
+            <p:ph type="sldNum" sz="quarter" idx="5"/>
+          </p:nvPr>
+        </p:nvSpPr>
+        <p:spPr/>
+        <p:txBody>
+          <a:bodyPr/>
+          <a:lstStyle/>
+          <a:p>
+            <a:fld id="{ECB4FCA9-8494-4F56-8FA5-838D269428B5}" type="slidenum">
+              <a:rPr lang="en-US" smtClean="0"/>
+              <a:t>5</a:t>
+            </a:fld>
+            <a:endParaRPr lang="en-US"/>
+          </a:p>
+        </p:txBody>
+      </p:sp>
+    </p:spTree>
+    <p:extLst>
+      <p:ext uri="{BB962C8B-B14F-4D97-AF65-F5344CB8AC3E}">
+        <p14:creationId xmlns:p14="http://schemas.microsoft.com/office/powerpoint/2010/main" val="2200186525"/>
+      </p:ext>
+    </p:extLst>
+  </p:cSld>
+  <p:clrMapOvr>
+    <a:masterClrMapping/>
+  </p:clrMapOvr>
+</p:notes>
+</file>
+
+<file path=ppt/notesSlides/notesSlide2.xml><?xml version="1.0" encoding="utf-8"?>
+<p:notes xmlns:a="http://schemas.openxmlformats.org/drawingml/2006/main" xmlns:r="http://schemas.openxmlformats.org/officeDocument/2006/relationships" xmlns:p="http://schemas.openxmlformats.org/presentationml/2006/main">
+  <p:cSld>
+    <p:spTree>
+      <p:nvGrpSpPr>
+        <p:cNvPr id="1" name=""/>
+        <p:cNvGrpSpPr/>
+        <p:nvPr/>
+      </p:nvGrpSpPr>
+      <p:grpSpPr>
+        <a:xfrm>
+          <a:off x="0" y="0"/>
+          <a:ext cx="0" cy="0"/>
+          <a:chOff x="0" y="0"/>
+          <a:chExt cx="0" cy="0"/>
+        </a:xfrm>
+      </p:grpSpPr>
+      <p:sp>
+        <p:nvSpPr>
+          <p:cNvPr id="2" name="Slide Image Placeholder 1"/>
+          <p:cNvSpPr>
+            <a:spLocks noGrp="1" noRot="1" noChangeAspect="1"/>
+          </p:cNvSpPr>
+          <p:nvPr>
+            <p:ph type="sldImg"/>
+          </p:nvPr>
+        </p:nvSpPr>
+        <p:spPr/>
+      </p:sp>
+      <p:sp>
+        <p:nvSpPr>
+          <p:cNvPr id="3" name="Notes Placeholder 2"/>
+          <p:cNvSpPr>
+            <a:spLocks noGrp="1"/>
+          </p:cNvSpPr>
+          <p:nvPr>
+            <p:ph type="body" idx="1"/>
+          </p:nvPr>
+        </p:nvSpPr>
+        <p:spPr/>
+        <p:txBody>
+          <a:bodyPr/>
+          <a:lstStyle/>
+          <a:p>
+            <a:endParaRPr lang="en-US" dirty="0"/>
+          </a:p>
+        </p:txBody>
+      </p:sp>
+      <p:sp>
+        <p:nvSpPr>
+          <p:cNvPr id="4" name="Slide Number Placeholder 3"/>
+          <p:cNvSpPr>
+            <a:spLocks noGrp="1"/>
+          </p:cNvSpPr>
+          <p:nvPr>
+            <p:ph type="sldNum" sz="quarter" idx="5"/>
+          </p:nvPr>
+        </p:nvSpPr>
+        <p:spPr/>
+        <p:txBody>
+          <a:bodyPr/>
+          <a:lstStyle/>
+          <a:p>
+            <a:fld id="{ECB4FCA9-8494-4F56-8FA5-838D269428B5}" type="slidenum">
+              <a:rPr lang="en-US" smtClean="0"/>
+              <a:t>7</a:t>
+            </a:fld>
+            <a:endParaRPr lang="en-US"/>
+          </a:p>
+        </p:txBody>
+      </p:sp>
+    </p:spTree>
+    <p:extLst>
+      <p:ext uri="{BB962C8B-B14F-4D97-AF65-F5344CB8AC3E}">
+        <p14:creationId xmlns:p14="http://schemas.microsoft.com/office/powerpoint/2010/main" val="2203245257"/>
+      </p:ext>
+    </p:extLst>
+  </p:cSld>
+  <p:clrMapOvr>
+    <a:masterClrMapping/>
+  </p:clrMapOvr>
+</p:notes>
+</file>
+
 <file path=ppt/slideLayouts/slideLayout1.xml><?xml version="1.0" encoding="utf-8"?>
 <p:sldLayout xmlns:a="http://schemas.openxmlformats.org/drawingml/2006/main" xmlns:r="http://schemas.openxmlformats.org/officeDocument/2006/relationships" xmlns:p="http://schemas.openxmlformats.org/presentationml/2006/main" type="title" preserve="1">
   <p:cSld name="Title Slide">
@@ -264,7 +786,7 @@
           <a:p>
             <a:fld id="{4A227F7C-5135-49D1-B6CF-8F631C0E6D17}" type="datetimeFigureOut">
               <a:rPr lang="en-US" smtClean="0"/>
-              <a:t>5/4/2026</a:t>
+              <a:t>5/5/2026</a:t>
             </a:fld>
             <a:endParaRPr lang="en-US"/>
           </a:p>
@@ -462,7 +984,7 @@
           <a:p>
             <a:fld id="{4A227F7C-5135-49D1-B6CF-8F631C0E6D17}" type="datetimeFigureOut">
               <a:rPr lang="en-US" smtClean="0"/>
-              <a:t>5/4/2026</a:t>
+              <a:t>5/5/2026</a:t>
             </a:fld>
             <a:endParaRPr lang="en-US"/>
           </a:p>
@@ -670,7 +1192,7 @@
           <a:p>
             <a:fld id="{4A227F7C-5135-49D1-B6CF-8F631C0E6D17}" type="datetimeFigureOut">
               <a:rPr lang="en-US" smtClean="0"/>
-              <a:t>5/4/2026</a:t>
+              <a:t>5/5/2026</a:t>
             </a:fld>
             <a:endParaRPr lang="en-US"/>
           </a:p>
@@ -868,7 +1390,7 @@
           <a:p>
             <a:fld id="{4A227F7C-5135-49D1-B6CF-8F631C0E6D17}" type="datetimeFigureOut">
               <a:rPr lang="en-US" smtClean="0"/>
-              <a:t>5/4/2026</a:t>
+              <a:t>5/5/2026</a:t>
             </a:fld>
             <a:endParaRPr lang="en-US"/>
           </a:p>
@@ -1143,7 +1665,7 @@
           <a:p>
             <a:fld id="{4A227F7C-5135-49D1-B6CF-8F631C0E6D17}" type="datetimeFigureOut">
               <a:rPr lang="en-US" smtClean="0"/>
-              <a:t>5/4/2026</a:t>
+              <a:t>5/5/2026</a:t>
             </a:fld>
             <a:endParaRPr lang="en-US"/>
           </a:p>
@@ -1408,7 +1930,7 @@
           <a:p>
             <a:fld id="{4A227F7C-5135-49D1-B6CF-8F631C0E6D17}" type="datetimeFigureOut">
               <a:rPr lang="en-US" smtClean="0"/>
-              <a:t>5/4/2026</a:t>
+              <a:t>5/5/2026</a:t>
             </a:fld>
             <a:endParaRPr lang="en-US"/>
           </a:p>
@@ -1820,7 +2342,7 @@
           <a:p>
             <a:fld id="{4A227F7C-5135-49D1-B6CF-8F631C0E6D17}" type="datetimeFigureOut">
               <a:rPr lang="en-US" smtClean="0"/>
-              <a:t>5/4/2026</a:t>
+              <a:t>5/5/2026</a:t>
             </a:fld>
             <a:endParaRPr lang="en-US"/>
           </a:p>
@@ -1961,7 +2483,7 @@
           <a:p>
             <a:fld id="{4A227F7C-5135-49D1-B6CF-8F631C0E6D17}" type="datetimeFigureOut">
               <a:rPr lang="en-US" smtClean="0"/>
-              <a:t>5/4/2026</a:t>
+              <a:t>5/5/2026</a:t>
             </a:fld>
             <a:endParaRPr lang="en-US"/>
           </a:p>
@@ -2074,7 +2596,7 @@
           <a:p>
             <a:fld id="{4A227F7C-5135-49D1-B6CF-8F631C0E6D17}" type="datetimeFigureOut">
               <a:rPr lang="en-US" smtClean="0"/>
-              <a:t>5/4/2026</a:t>
+              <a:t>5/5/2026</a:t>
             </a:fld>
             <a:endParaRPr lang="en-US"/>
           </a:p>
@@ -2385,7 +2907,7 @@
           <a:p>
             <a:fld id="{4A227F7C-5135-49D1-B6CF-8F631C0E6D17}" type="datetimeFigureOut">
               <a:rPr lang="en-US" smtClean="0"/>
-              <a:t>5/4/2026</a:t>
+              <a:t>5/5/2026</a:t>
             </a:fld>
             <a:endParaRPr lang="en-US"/>
           </a:p>
@@ -2673,7 +3195,7 @@
           <a:p>
             <a:fld id="{4A227F7C-5135-49D1-B6CF-8F631C0E6D17}" type="datetimeFigureOut">
               <a:rPr lang="en-US" smtClean="0"/>
-              <a:t>5/4/2026</a:t>
+              <a:t>5/5/2026</a:t>
             </a:fld>
             <a:endParaRPr lang="en-US"/>
           </a:p>
@@ -2914,7 +3436,7 @@
           <a:p>
             <a:fld id="{4A227F7C-5135-49D1-B6CF-8F631C0E6D17}" type="datetimeFigureOut">
               <a:rPr lang="en-US" smtClean="0"/>
-              <a:t>5/4/2026</a:t>
+              <a:t>5/5/2026</a:t>
             </a:fld>
             <a:endParaRPr lang="en-US"/>
           </a:p>
@@ -5406,7 +5928,7 @@
                   </a:schemeClr>
                 </a:solidFill>
               </a:rPr>
-              <a:t>Increments of 100</a:t>
+              <a:t>Increases with speed value</a:t>
             </a:r>
           </a:p>
         </p:txBody>
@@ -6037,19 +6559,17 @@
       </p:sp>
       <p:pic>
         <p:nvPicPr>
-          <p:cNvPr id="11" name="Content Placeholder 10">
-            <a:extLst>
-              <a:ext uri="{FF2B5EF4-FFF2-40B4-BE49-F238E27FC236}">
-                <a16:creationId xmlns:a16="http://schemas.microsoft.com/office/drawing/2014/main" id="{6B183045-37F2-BAEB-951F-99D0FB12F3F3}"/>
+          <p:cNvPr id="13" name="Picture 12">
+            <a:extLst>
+              <a:ext uri="{FF2B5EF4-FFF2-40B4-BE49-F238E27FC236}">
+                <a16:creationId xmlns:a16="http://schemas.microsoft.com/office/drawing/2014/main" id="{2C55205E-B006-F66F-9522-B3B5014A1014}"/>
               </a:ext>
             </a:extLst>
           </p:cNvPr>
           <p:cNvPicPr>
-            <a:picLocks noGrp="1" noChangeAspect="1"/>
+            <a:picLocks noChangeAspect="1"/>
           </p:cNvPicPr>
-          <p:nvPr>
-            <p:ph idx="1"/>
-          </p:nvPr>
+          <p:nvPr/>
         </p:nvPicPr>
         <p:blipFill>
           <a:blip r:embed="rId2"/>
@@ -6059,8 +6579,8 @@
         </p:blipFill>
         <p:spPr>
           <a:xfrm>
-            <a:off x="715748" y="2194292"/>
-            <a:ext cx="5131088" cy="3971905"/>
+            <a:off x="6562584" y="1576447"/>
+            <a:ext cx="3755923" cy="5271472"/>
           </a:xfrm>
           <a:prstGeom prst="rect">
             <a:avLst/>
@@ -6069,17 +6589,19 @@
       </p:pic>
       <p:pic>
         <p:nvPicPr>
-          <p:cNvPr id="13" name="Picture 12">
-            <a:extLst>
-              <a:ext uri="{FF2B5EF4-FFF2-40B4-BE49-F238E27FC236}">
-                <a16:creationId xmlns:a16="http://schemas.microsoft.com/office/drawing/2014/main" id="{2C55205E-B006-F66F-9522-B3B5014A1014}"/>
+          <p:cNvPr id="6" name="Content Placeholder 5">
+            <a:extLst>
+              <a:ext uri="{FF2B5EF4-FFF2-40B4-BE49-F238E27FC236}">
+                <a16:creationId xmlns:a16="http://schemas.microsoft.com/office/drawing/2014/main" id="{8B59FAFD-217B-7F03-4413-B706DFE48E52}"/>
               </a:ext>
             </a:extLst>
           </p:cNvPr>
           <p:cNvPicPr>
-            <a:picLocks noChangeAspect="1"/>
+            <a:picLocks noGrp="1" noChangeAspect="1"/>
           </p:cNvPicPr>
-          <p:nvPr/>
+          <p:nvPr>
+            <p:ph idx="1"/>
+          </p:nvPr>
         </p:nvPicPr>
         <p:blipFill>
           <a:blip r:embed="rId3"/>
@@ -6089,8 +6611,8 @@
         </p:blipFill>
         <p:spPr>
           <a:xfrm>
-            <a:off x="6562584" y="1576447"/>
-            <a:ext cx="3755923" cy="5271472"/>
+            <a:off x="289212" y="1775799"/>
+            <a:ext cx="5806788" cy="4507013"/>
           </a:xfrm>
           <a:prstGeom prst="rect">
             <a:avLst/>
@@ -6652,10 +7174,10 @@
       </p:sp>
       <p:pic>
         <p:nvPicPr>
-          <p:cNvPr id="4" name="Content Placeholder 3">
-            <a:extLst>
-              <a:ext uri="{FF2B5EF4-FFF2-40B4-BE49-F238E27FC236}">
-                <a16:creationId xmlns:a16="http://schemas.microsoft.com/office/drawing/2014/main" id="{77D90E08-571D-7557-43FC-29B8BBD12479}"/>
+          <p:cNvPr id="7" name="Content Placeholder 6">
+            <a:extLst>
+              <a:ext uri="{FF2B5EF4-FFF2-40B4-BE49-F238E27FC236}">
+                <a16:creationId xmlns:a16="http://schemas.microsoft.com/office/drawing/2014/main" id="{8A781C97-ED65-26E2-92A7-C8E3E812B96F}"/>
               </a:ext>
             </a:extLst>
           </p:cNvPr>
@@ -6674,8 +7196,38 @@
         </p:blipFill>
         <p:spPr>
           <a:xfrm>
-            <a:off x="4038604" y="845422"/>
-            <a:ext cx="8153396" cy="4667817"/>
+            <a:off x="4143839" y="100297"/>
+            <a:ext cx="7926241" cy="3586800"/>
+          </a:xfrm>
+          <a:prstGeom prst="rect">
+            <a:avLst/>
+          </a:prstGeom>
+        </p:spPr>
+      </p:pic>
+      <p:pic>
+        <p:nvPicPr>
+          <p:cNvPr id="10" name="Picture 9">
+            <a:extLst>
+              <a:ext uri="{FF2B5EF4-FFF2-40B4-BE49-F238E27FC236}">
+                <a16:creationId xmlns:a16="http://schemas.microsoft.com/office/drawing/2014/main" id="{1FA4F15D-B466-87CB-D368-E807DD37C77F}"/>
+              </a:ext>
+            </a:extLst>
+          </p:cNvPr>
+          <p:cNvPicPr>
+            <a:picLocks noChangeAspect="1"/>
+          </p:cNvPicPr>
+          <p:nvPr/>
+        </p:nvPicPr>
+        <p:blipFill>
+          <a:blip r:embed="rId3"/>
+          <a:stretch>
+            <a:fillRect/>
+          </a:stretch>
+        </p:blipFill>
+        <p:spPr>
+          <a:xfrm>
+            <a:off x="4164163" y="3787394"/>
+            <a:ext cx="8007514" cy="2497393"/>
           </a:xfrm>
           <a:prstGeom prst="rect">
             <a:avLst/>
@@ -6929,39 +7481,6 @@
           </a:p>
         </p:txBody>
       </p:sp>
-      <p:pic>
-        <p:nvPicPr>
-          <p:cNvPr id="9" name="Content Placeholder 8">
-            <a:extLst>
-              <a:ext uri="{FF2B5EF4-FFF2-40B4-BE49-F238E27FC236}">
-                <a16:creationId xmlns:a16="http://schemas.microsoft.com/office/drawing/2014/main" id="{376FF8CD-F849-729F-5D1C-94538062A7C7}"/>
-              </a:ext>
-            </a:extLst>
-          </p:cNvPr>
-          <p:cNvPicPr>
-            <a:picLocks noGrp="1" noChangeAspect="1"/>
-          </p:cNvPicPr>
-          <p:nvPr>
-            <p:ph idx="1"/>
-          </p:nvPr>
-        </p:nvPicPr>
-        <p:blipFill>
-          <a:blip r:embed="rId2"/>
-          <a:srcRect r="20486"/>
-          <a:stretch>
-            <a:fillRect/>
-          </a:stretch>
-        </p:blipFill>
-        <p:spPr>
-          <a:xfrm>
-            <a:off x="4038599" y="10"/>
-            <a:ext cx="8160026" cy="6875809"/>
-          </a:xfrm>
-          <a:prstGeom prst="rect">
-            <a:avLst/>
-          </a:prstGeom>
-        </p:spPr>
-      </p:pic>
       <p:sp>
         <p:nvSpPr>
           <p:cNvPr id="45" name="Freeform: Shape 44">
@@ -7175,6 +7694,38 @@
           </a:p>
         </p:txBody>
       </p:sp>
+      <p:pic>
+        <p:nvPicPr>
+          <p:cNvPr id="6" name="Content Placeholder 5">
+            <a:extLst>
+              <a:ext uri="{FF2B5EF4-FFF2-40B4-BE49-F238E27FC236}">
+                <a16:creationId xmlns:a16="http://schemas.microsoft.com/office/drawing/2014/main" id="{9AB33AF2-DB10-93B6-9B17-056170F1415C}"/>
+              </a:ext>
+            </a:extLst>
+          </p:cNvPr>
+          <p:cNvPicPr>
+            <a:picLocks noGrp="1" noChangeAspect="1"/>
+          </p:cNvPicPr>
+          <p:nvPr>
+            <p:ph idx="1"/>
+          </p:nvPr>
+        </p:nvPicPr>
+        <p:blipFill>
+          <a:blip r:embed="rId3"/>
+          <a:stretch>
+            <a:fillRect/>
+          </a:stretch>
+        </p:blipFill>
+        <p:spPr>
+          <a:xfrm>
+            <a:off x="4054075" y="624484"/>
+            <a:ext cx="8120314" cy="5626849"/>
+          </a:xfrm>
+          <a:prstGeom prst="rect">
+            <a:avLst/>
+          </a:prstGeom>
+        </p:spPr>
+      </p:pic>
     </p:spTree>
     <p:extLst>
       <p:ext uri="{BB962C8B-B14F-4D97-AF65-F5344CB8AC3E}">
@@ -7422,39 +7973,6 @@
           </a:p>
         </p:txBody>
       </p:sp>
-      <p:pic>
-        <p:nvPicPr>
-          <p:cNvPr id="9" name="Content Placeholder 8">
-            <a:extLst>
-              <a:ext uri="{FF2B5EF4-FFF2-40B4-BE49-F238E27FC236}">
-                <a16:creationId xmlns:a16="http://schemas.microsoft.com/office/drawing/2014/main" id="{779FF403-B31D-BCA4-DA73-B4EDF8861EAD}"/>
-              </a:ext>
-            </a:extLst>
-          </p:cNvPr>
-          <p:cNvPicPr>
-            <a:picLocks noGrp="1" noChangeAspect="1"/>
-          </p:cNvPicPr>
-          <p:nvPr>
-            <p:ph idx="1"/>
-          </p:nvPr>
-        </p:nvPicPr>
-        <p:blipFill>
-          <a:blip r:embed="rId2"/>
-          <a:srcRect r="8618"/>
-          <a:stretch>
-            <a:fillRect/>
-          </a:stretch>
-        </p:blipFill>
-        <p:spPr>
-          <a:xfrm>
-            <a:off x="4038599" y="10"/>
-            <a:ext cx="8160026" cy="6875809"/>
-          </a:xfrm>
-          <a:prstGeom prst="rect">
-            <a:avLst/>
-          </a:prstGeom>
-        </p:spPr>
-      </p:pic>
       <p:sp>
         <p:nvSpPr>
           <p:cNvPr id="27" name="Freeform: Shape 26">
@@ -7668,10 +8186,1033 @@
           </a:p>
         </p:txBody>
       </p:sp>
+      <p:pic>
+        <p:nvPicPr>
+          <p:cNvPr id="6" name="Content Placeholder 5">
+            <a:extLst>
+              <a:ext uri="{FF2B5EF4-FFF2-40B4-BE49-F238E27FC236}">
+                <a16:creationId xmlns:a16="http://schemas.microsoft.com/office/drawing/2014/main" id="{E1C0395E-69F3-24FB-A7AD-2180D5FBAB4B}"/>
+              </a:ext>
+            </a:extLst>
+          </p:cNvPr>
+          <p:cNvPicPr>
+            <a:picLocks noGrp="1" noChangeAspect="1"/>
+          </p:cNvPicPr>
+          <p:nvPr>
+            <p:ph idx="1"/>
+          </p:nvPr>
+        </p:nvPicPr>
+        <p:blipFill>
+          <a:blip r:embed="rId2"/>
+          <a:stretch>
+            <a:fillRect/>
+          </a:stretch>
+        </p:blipFill>
+        <p:spPr>
+          <a:xfrm>
+            <a:off x="4038603" y="9500"/>
+            <a:ext cx="7474971" cy="6812166"/>
+          </a:xfrm>
+          <a:prstGeom prst="rect">
+            <a:avLst/>
+          </a:prstGeom>
+        </p:spPr>
+      </p:pic>
     </p:spTree>
     <p:extLst>
       <p:ext uri="{BB962C8B-B14F-4D97-AF65-F5344CB8AC3E}">
         <p14:creationId xmlns:p14="http://schemas.microsoft.com/office/powerpoint/2010/main" val="3122901497"/>
+      </p:ext>
+    </p:extLst>
+  </p:cSld>
+  <p:clrMapOvr>
+    <a:masterClrMapping/>
+  </p:clrMapOvr>
+</p:sld>
+</file>
+
+<file path=ppt/slides/slide7.xml><?xml version="1.0" encoding="utf-8"?>
+<p:sld xmlns:a="http://schemas.openxmlformats.org/drawingml/2006/main" xmlns:r="http://schemas.openxmlformats.org/officeDocument/2006/relationships" xmlns:p="http://schemas.openxmlformats.org/presentationml/2006/main">
+  <p:cSld>
+    <p:bg>
+      <p:bgPr>
+        <a:solidFill>
+          <a:schemeClr val="bg1"/>
+        </a:solidFill>
+        <a:effectLst/>
+      </p:bgPr>
+    </p:bg>
+    <p:spTree>
+      <p:nvGrpSpPr>
+        <p:cNvPr id="1" name="">
+          <a:extLst>
+            <a:ext uri="{FF2B5EF4-FFF2-40B4-BE49-F238E27FC236}">
+              <a16:creationId xmlns:a16="http://schemas.microsoft.com/office/drawing/2014/main" id="{E7B2FEF0-AE93-DF3D-A51E-80A0682DB062}"/>
+            </a:ext>
+          </a:extLst>
+        </p:cNvPr>
+        <p:cNvGrpSpPr/>
+        <p:nvPr/>
+      </p:nvGrpSpPr>
+      <p:grpSpPr>
+        <a:xfrm>
+          <a:off x="0" y="0"/>
+          <a:ext cx="0" cy="0"/>
+          <a:chOff x="0" y="0"/>
+          <a:chExt cx="0" cy="0"/>
+        </a:xfrm>
+      </p:grpSpPr>
+      <p:sp useBgFill="1">
+        <p:nvSpPr>
+          <p:cNvPr id="21" name="Rectangle 20">
+            <a:extLst>
+              <a:ext uri="{FF2B5EF4-FFF2-40B4-BE49-F238E27FC236}">
+                <a16:creationId xmlns:a16="http://schemas.microsoft.com/office/drawing/2014/main" id="{69359FFD-453E-7054-B6CD-1DEE606678BA}"/>
+              </a:ext>
+              <a:ext uri="{C183D7F6-B498-43B3-948B-1728B52AA6E4}">
+                <adec:decorative xmlns:adec="http://schemas.microsoft.com/office/drawing/2017/decorative" val="1"/>
+              </a:ext>
+            </a:extLst>
+          </p:cNvPr>
+          <p:cNvSpPr>
+            <a:spLocks noGrp="1" noRot="1" noChangeAspect="1" noMove="1" noResize="1" noEditPoints="1" noAdjustHandles="1" noChangeArrowheads="1" noChangeShapeType="1" noTextEdit="1"/>
+          </p:cNvSpPr>
+          <p:nvPr>
+            <p:extLst>
+              <p:ext uri="{386F3935-93C4-4BCD-93E2-E3B085C9AB24}">
+                <p16:designElem xmlns:p16="http://schemas.microsoft.com/office/powerpoint/2015/main" val="1"/>
+              </p:ext>
+            </p:extLst>
+          </p:nvPr>
+        </p:nvSpPr>
+        <p:spPr>
+          <a:xfrm>
+            <a:off x="0" y="2"/>
+            <a:ext cx="12192000" cy="6857997"/>
+          </a:xfrm>
+          <a:prstGeom prst="rect">
+            <a:avLst/>
+          </a:prstGeom>
+          <a:ln>
+            <a:noFill/>
+          </a:ln>
+        </p:spPr>
+        <p:style>
+          <a:lnRef idx="2">
+            <a:schemeClr val="accent1">
+              <a:shade val="50000"/>
+            </a:schemeClr>
+          </a:lnRef>
+          <a:fillRef idx="1">
+            <a:schemeClr val="accent1"/>
+          </a:fillRef>
+          <a:effectRef idx="0">
+            <a:schemeClr val="accent1"/>
+          </a:effectRef>
+          <a:fontRef idx="minor">
+            <a:schemeClr val="lt1"/>
+          </a:fontRef>
+        </p:style>
+        <p:txBody>
+          <a:bodyPr rtlCol="0" anchor="ctr"/>
+          <a:lstStyle/>
+          <a:p>
+            <a:pPr algn="ctr"/>
+            <a:endParaRPr lang="en-US"/>
+          </a:p>
+        </p:txBody>
+      </p:sp>
+      <p:sp>
+        <p:nvSpPr>
+          <p:cNvPr id="23" name="Rectangle 22">
+            <a:extLst>
+              <a:ext uri="{FF2B5EF4-FFF2-40B4-BE49-F238E27FC236}">
+                <a16:creationId xmlns:a16="http://schemas.microsoft.com/office/drawing/2014/main" id="{6C0F2870-D9DC-6ABD-5252-9C583FEBA666}"/>
+              </a:ext>
+              <a:ext uri="{C183D7F6-B498-43B3-948B-1728B52AA6E4}">
+                <adec:decorative xmlns:adec="http://schemas.microsoft.com/office/drawing/2017/decorative" val="1"/>
+              </a:ext>
+            </a:extLst>
+          </p:cNvPr>
+          <p:cNvSpPr>
+            <a:spLocks noGrp="1" noRot="1" noChangeAspect="1" noMove="1" noResize="1" noEditPoints="1" noAdjustHandles="1" noChangeArrowheads="1" noChangeShapeType="1" noTextEdit="1"/>
+          </p:cNvSpPr>
+          <p:nvPr>
+            <p:extLst>
+              <p:ext uri="{386F3935-93C4-4BCD-93E2-E3B085C9AB24}">
+                <p16:designElem xmlns:p16="http://schemas.microsoft.com/office/powerpoint/2015/main" val="1"/>
+              </p:ext>
+            </p:extLst>
+          </p:nvPr>
+        </p:nvSpPr>
+        <p:spPr>
+          <a:xfrm rot="5400000" flipH="1">
+            <a:off x="-1417539" y="1417538"/>
+            <a:ext cx="6875818" cy="4040744"/>
+          </a:xfrm>
+          <a:prstGeom prst="rect">
+            <a:avLst/>
+          </a:prstGeom>
+          <a:gradFill>
+            <a:gsLst>
+              <a:gs pos="11000">
+                <a:srgbClr val="000000"/>
+              </a:gs>
+              <a:gs pos="100000">
+                <a:schemeClr val="accent1">
+                  <a:lumMod val="75000"/>
+                </a:schemeClr>
+              </a:gs>
+            </a:gsLst>
+            <a:lin ang="18600000" scaled="0"/>
+          </a:gradFill>
+          <a:ln>
+            <a:noFill/>
+          </a:ln>
+        </p:spPr>
+        <p:style>
+          <a:lnRef idx="2">
+            <a:schemeClr val="accent1">
+              <a:shade val="50000"/>
+            </a:schemeClr>
+          </a:lnRef>
+          <a:fillRef idx="1">
+            <a:schemeClr val="accent1"/>
+          </a:fillRef>
+          <a:effectRef idx="0">
+            <a:schemeClr val="accent1"/>
+          </a:effectRef>
+          <a:fontRef idx="minor">
+            <a:schemeClr val="lt1"/>
+          </a:fontRef>
+        </p:style>
+        <p:txBody>
+          <a:bodyPr rtlCol="0" anchor="ctr"/>
+          <a:lstStyle/>
+          <a:p>
+            <a:pPr algn="ctr"/>
+            <a:endParaRPr lang="en-US" dirty="0"/>
+          </a:p>
+        </p:txBody>
+      </p:sp>
+      <p:sp>
+        <p:nvSpPr>
+          <p:cNvPr id="25" name="Rectangle 24">
+            <a:extLst>
+              <a:ext uri="{FF2B5EF4-FFF2-40B4-BE49-F238E27FC236}">
+                <a16:creationId xmlns:a16="http://schemas.microsoft.com/office/drawing/2014/main" id="{8045B1C3-2957-5D35-09CE-F15398346939}"/>
+              </a:ext>
+              <a:ext uri="{C183D7F6-B498-43B3-948B-1728B52AA6E4}">
+                <adec:decorative xmlns:adec="http://schemas.microsoft.com/office/drawing/2017/decorative" val="1"/>
+              </a:ext>
+            </a:extLst>
+          </p:cNvPr>
+          <p:cNvSpPr>
+            <a:spLocks noGrp="1" noRot="1" noChangeAspect="1" noMove="1" noResize="1" noEditPoints="1" noAdjustHandles="1" noChangeArrowheads="1" noChangeShapeType="1" noTextEdit="1"/>
+          </p:cNvSpPr>
+          <p:nvPr>
+            <p:extLst>
+              <p:ext uri="{386F3935-93C4-4BCD-93E2-E3B085C9AB24}">
+                <p16:designElem xmlns:p16="http://schemas.microsoft.com/office/powerpoint/2015/main" val="1"/>
+              </p:ext>
+            </p:extLst>
+          </p:nvPr>
+        </p:nvSpPr>
+        <p:spPr>
+          <a:xfrm rot="16200000">
+            <a:off x="-159565" y="2659404"/>
+            <a:ext cx="4355594" cy="4040742"/>
+          </a:xfrm>
+          <a:prstGeom prst="rect">
+            <a:avLst/>
+          </a:prstGeom>
+          <a:gradFill>
+            <a:gsLst>
+              <a:gs pos="0">
+                <a:schemeClr val="accent1">
+                  <a:alpha val="50000"/>
+                </a:schemeClr>
+              </a:gs>
+              <a:gs pos="100000">
+                <a:schemeClr val="accent1">
+                  <a:lumMod val="50000"/>
+                  <a:alpha val="0"/>
+                </a:schemeClr>
+              </a:gs>
+            </a:gsLst>
+            <a:lin ang="11400000" scaled="0"/>
+          </a:gradFill>
+          <a:ln>
+            <a:noFill/>
+          </a:ln>
+        </p:spPr>
+        <p:style>
+          <a:lnRef idx="2">
+            <a:schemeClr val="accent1">
+              <a:shade val="50000"/>
+            </a:schemeClr>
+          </a:lnRef>
+          <a:fillRef idx="1">
+            <a:schemeClr val="accent1"/>
+          </a:fillRef>
+          <a:effectRef idx="0">
+            <a:schemeClr val="accent1"/>
+          </a:effectRef>
+          <a:fontRef idx="minor">
+            <a:schemeClr val="lt1"/>
+          </a:fontRef>
+        </p:style>
+        <p:txBody>
+          <a:bodyPr rtlCol="0" anchor="ctr"/>
+          <a:lstStyle/>
+          <a:p>
+            <a:pPr algn="ctr"/>
+            <a:endParaRPr lang="en-US"/>
+          </a:p>
+        </p:txBody>
+      </p:sp>
+      <p:sp>
+        <p:nvSpPr>
+          <p:cNvPr id="27" name="Freeform: Shape 26">
+            <a:extLst>
+              <a:ext uri="{FF2B5EF4-FFF2-40B4-BE49-F238E27FC236}">
+                <a16:creationId xmlns:a16="http://schemas.microsoft.com/office/drawing/2014/main" id="{5B8ED189-DCA1-86F8-C082-19622E07E320}"/>
+              </a:ext>
+              <a:ext uri="{C183D7F6-B498-43B3-948B-1728B52AA6E4}">
+                <adec:decorative xmlns:adec="http://schemas.microsoft.com/office/drawing/2017/decorative" val="1"/>
+              </a:ext>
+            </a:extLst>
+          </p:cNvPr>
+          <p:cNvSpPr>
+            <a:spLocks noGrp="1" noRot="1" noChangeAspect="1" noMove="1" noResize="1" noEditPoints="1" noAdjustHandles="1" noChangeArrowheads="1" noChangeShapeType="1" noTextEdit="1"/>
+          </p:cNvSpPr>
+          <p:nvPr>
+            <p:extLst>
+              <p:ext uri="{386F3935-93C4-4BCD-93E2-E3B085C9AB24}">
+                <p16:designElem xmlns:p16="http://schemas.microsoft.com/office/powerpoint/2015/main" val="1"/>
+              </p:ext>
+            </p:extLst>
+          </p:nvPr>
+        </p:nvSpPr>
+        <p:spPr>
+          <a:xfrm rot="6097846">
+            <a:off x="-747355" y="1201312"/>
+            <a:ext cx="4808302" cy="4088666"/>
+          </a:xfrm>
+          <a:custGeom>
+            <a:avLst/>
+            <a:gdLst>
+              <a:gd name="connsiteX0" fmla="*/ 48844 w 4808302"/>
+              <a:gd name="connsiteY0" fmla="*/ 2888671 h 4088666"/>
+              <a:gd name="connsiteX1" fmla="*/ 0 w 4808302"/>
+              <a:gd name="connsiteY1" fmla="*/ 2404151 h 4088666"/>
+              <a:gd name="connsiteX2" fmla="*/ 2404151 w 4808302"/>
+              <a:gd name="connsiteY2" fmla="*/ 0 h 4088666"/>
+              <a:gd name="connsiteX3" fmla="*/ 4808302 w 4808302"/>
+              <a:gd name="connsiteY3" fmla="*/ 2404151 h 4088666"/>
+              <a:gd name="connsiteX4" fmla="*/ 4700216 w 4808302"/>
+              <a:gd name="connsiteY4" fmla="*/ 3119072 h 4088666"/>
+              <a:gd name="connsiteX5" fmla="*/ 4643143 w 4808302"/>
+              <a:gd name="connsiteY5" fmla="*/ 3275009 h 4088666"/>
+              <a:gd name="connsiteX6" fmla="*/ 690093 w 4808302"/>
+              <a:gd name="connsiteY6" fmla="*/ 4088666 h 4088666"/>
+              <a:gd name="connsiteX7" fmla="*/ 548991 w 4808302"/>
+              <a:gd name="connsiteY7" fmla="*/ 3933414 h 4088666"/>
+              <a:gd name="connsiteX8" fmla="*/ 48844 w 4808302"/>
+              <a:gd name="connsiteY8" fmla="*/ 2888671 h 4088666"/>
+            </a:gdLst>
+            <a:ahLst/>
+            <a:cxnLst>
+              <a:cxn ang="0">
+                <a:pos x="connsiteX0" y="connsiteY0"/>
+              </a:cxn>
+              <a:cxn ang="0">
+                <a:pos x="connsiteX1" y="connsiteY1"/>
+              </a:cxn>
+              <a:cxn ang="0">
+                <a:pos x="connsiteX2" y="connsiteY2"/>
+              </a:cxn>
+              <a:cxn ang="0">
+                <a:pos x="connsiteX3" y="connsiteY3"/>
+              </a:cxn>
+              <a:cxn ang="0">
+                <a:pos x="connsiteX4" y="connsiteY4"/>
+              </a:cxn>
+              <a:cxn ang="0">
+                <a:pos x="connsiteX5" y="connsiteY5"/>
+              </a:cxn>
+              <a:cxn ang="0">
+                <a:pos x="connsiteX6" y="connsiteY6"/>
+              </a:cxn>
+              <a:cxn ang="0">
+                <a:pos x="connsiteX7" y="connsiteY7"/>
+              </a:cxn>
+              <a:cxn ang="0">
+                <a:pos x="connsiteX8" y="connsiteY8"/>
+              </a:cxn>
+            </a:cxnLst>
+            <a:rect l="l" t="t" r="r" b="b"/>
+            <a:pathLst>
+              <a:path w="4808302" h="4088666">
+                <a:moveTo>
+                  <a:pt x="48844" y="2888671"/>
+                </a:moveTo>
+                <a:cubicBezTo>
+                  <a:pt x="16818" y="2732167"/>
+                  <a:pt x="0" y="2570123"/>
+                  <a:pt x="0" y="2404151"/>
+                </a:cubicBezTo>
+                <a:cubicBezTo>
+                  <a:pt x="0" y="1076375"/>
+                  <a:pt x="1076375" y="0"/>
+                  <a:pt x="2404151" y="0"/>
+                </a:cubicBezTo>
+                <a:cubicBezTo>
+                  <a:pt x="3731927" y="0"/>
+                  <a:pt x="4808302" y="1076375"/>
+                  <a:pt x="4808302" y="2404151"/>
+                </a:cubicBezTo>
+                <a:cubicBezTo>
+                  <a:pt x="4808302" y="2653109"/>
+                  <a:pt x="4770461" y="2893229"/>
+                  <a:pt x="4700216" y="3119072"/>
+                </a:cubicBezTo>
+                <a:lnTo>
+                  <a:pt x="4643143" y="3275009"/>
+                </a:lnTo>
+                <a:lnTo>
+                  <a:pt x="690093" y="4088666"/>
+                </a:lnTo>
+                <a:lnTo>
+                  <a:pt x="548991" y="3933414"/>
+                </a:lnTo>
+                <a:cubicBezTo>
+                  <a:pt x="304015" y="3636572"/>
+                  <a:pt x="128908" y="3279932"/>
+                  <a:pt x="48844" y="2888671"/>
+                </a:cubicBezTo>
+                <a:close/>
+              </a:path>
+            </a:pathLst>
+          </a:custGeom>
+          <a:gradFill>
+            <a:gsLst>
+              <a:gs pos="39000">
+                <a:schemeClr val="accent1">
+                  <a:lumMod val="60000"/>
+                  <a:lumOff val="40000"/>
+                  <a:alpha val="0"/>
+                </a:schemeClr>
+              </a:gs>
+              <a:gs pos="100000">
+                <a:schemeClr val="accent1">
+                  <a:lumMod val="75000"/>
+                  <a:alpha val="26000"/>
+                </a:schemeClr>
+              </a:gs>
+            </a:gsLst>
+            <a:lin ang="16800000" scaled="0"/>
+          </a:gradFill>
+          <a:ln>
+            <a:noFill/>
+          </a:ln>
+        </p:spPr>
+        <p:style>
+          <a:lnRef idx="2">
+            <a:schemeClr val="accent1">
+              <a:shade val="50000"/>
+            </a:schemeClr>
+          </a:lnRef>
+          <a:fillRef idx="1">
+            <a:schemeClr val="accent1"/>
+          </a:fillRef>
+          <a:effectRef idx="0">
+            <a:schemeClr val="accent1"/>
+          </a:effectRef>
+          <a:fontRef idx="minor">
+            <a:schemeClr val="lt1"/>
+          </a:fontRef>
+        </p:style>
+        <p:txBody>
+          <a:bodyPr wrap="square" rtlCol="0" anchor="ctr">
+            <a:noAutofit/>
+          </a:bodyPr>
+          <a:lstStyle/>
+          <a:p>
+            <a:pPr algn="ctr"/>
+            <a:endParaRPr lang="en-US" dirty="0"/>
+          </a:p>
+        </p:txBody>
+      </p:sp>
+      <p:sp>
+        <p:nvSpPr>
+          <p:cNvPr id="2" name="Title 1">
+            <a:extLst>
+              <a:ext uri="{FF2B5EF4-FFF2-40B4-BE49-F238E27FC236}">
+                <a16:creationId xmlns:a16="http://schemas.microsoft.com/office/drawing/2014/main" id="{0FB54EAE-7F2C-CB0F-6490-86F1CCFD7DC6}"/>
+              </a:ext>
+            </a:extLst>
+          </p:cNvPr>
+          <p:cNvSpPr>
+            <a:spLocks noGrp="1"/>
+          </p:cNvSpPr>
+          <p:nvPr>
+            <p:ph type="title"/>
+          </p:nvPr>
+        </p:nvSpPr>
+        <p:spPr>
+          <a:xfrm>
+            <a:off x="534473" y="2950387"/>
+            <a:ext cx="3052293" cy="3531403"/>
+          </a:xfrm>
+        </p:spPr>
+        <p:txBody>
+          <a:bodyPr vert="horz" lIns="91440" tIns="45720" rIns="91440" bIns="45720" rtlCol="0" anchor="t">
+            <a:normAutofit/>
+          </a:bodyPr>
+          <a:lstStyle/>
+          <a:p>
+            <a:pPr algn="r"/>
+            <a:r>
+              <a:rPr lang="en-US" sz="4000" dirty="0">
+                <a:solidFill>
+                  <a:srgbClr val="FFFFFF"/>
+                </a:solidFill>
+              </a:rPr>
+              <a:t>Main Game Loop Cont.</a:t>
+            </a:r>
+          </a:p>
+        </p:txBody>
+      </p:sp>
+      <p:pic>
+        <p:nvPicPr>
+          <p:cNvPr id="6" name="Content Placeholder 5">
+            <a:extLst>
+              <a:ext uri="{FF2B5EF4-FFF2-40B4-BE49-F238E27FC236}">
+                <a16:creationId xmlns:a16="http://schemas.microsoft.com/office/drawing/2014/main" id="{3A57F4BD-C261-8168-0FE4-3AA2CFA7946F}"/>
+              </a:ext>
+            </a:extLst>
+          </p:cNvPr>
+          <p:cNvPicPr>
+            <a:picLocks noGrp="1" noChangeAspect="1"/>
+          </p:cNvPicPr>
+          <p:nvPr>
+            <p:ph idx="1"/>
+          </p:nvPr>
+        </p:nvPicPr>
+        <p:blipFill>
+          <a:blip r:embed="rId3"/>
+          <a:stretch>
+            <a:fillRect/>
+          </a:stretch>
+        </p:blipFill>
+        <p:spPr>
+          <a:xfrm>
+            <a:off x="4102522" y="531728"/>
+            <a:ext cx="8089478" cy="5489760"/>
+          </a:xfrm>
+          <a:prstGeom prst="rect">
+            <a:avLst/>
+          </a:prstGeom>
+        </p:spPr>
+      </p:pic>
+    </p:spTree>
+    <p:extLst>
+      <p:ext uri="{BB962C8B-B14F-4D97-AF65-F5344CB8AC3E}">
+        <p14:creationId xmlns:p14="http://schemas.microsoft.com/office/powerpoint/2010/main" val="1147805342"/>
+      </p:ext>
+    </p:extLst>
+  </p:cSld>
+  <p:clrMapOvr>
+    <a:masterClrMapping/>
+  </p:clrMapOvr>
+</p:sld>
+</file>
+
+<file path=ppt/slides/slide8.xml><?xml version="1.0" encoding="utf-8"?>
+<p:sld xmlns:a="http://schemas.openxmlformats.org/drawingml/2006/main" xmlns:r="http://schemas.openxmlformats.org/officeDocument/2006/relationships" xmlns:p="http://schemas.openxmlformats.org/presentationml/2006/main">
+  <p:cSld>
+    <p:bg>
+      <p:bgPr>
+        <a:solidFill>
+          <a:schemeClr val="bg1"/>
+        </a:solidFill>
+        <a:effectLst/>
+      </p:bgPr>
+    </p:bg>
+    <p:spTree>
+      <p:nvGrpSpPr>
+        <p:cNvPr id="1" name="">
+          <a:extLst>
+            <a:ext uri="{FF2B5EF4-FFF2-40B4-BE49-F238E27FC236}">
+              <a16:creationId xmlns:a16="http://schemas.microsoft.com/office/drawing/2014/main" id="{86E930D7-D287-DE8B-CFDE-DC2061F6034C}"/>
+            </a:ext>
+          </a:extLst>
+        </p:cNvPr>
+        <p:cNvGrpSpPr/>
+        <p:nvPr/>
+      </p:nvGrpSpPr>
+      <p:grpSpPr>
+        <a:xfrm>
+          <a:off x="0" y="0"/>
+          <a:ext cx="0" cy="0"/>
+          <a:chOff x="0" y="0"/>
+          <a:chExt cx="0" cy="0"/>
+        </a:xfrm>
+      </p:grpSpPr>
+      <p:sp useBgFill="1">
+        <p:nvSpPr>
+          <p:cNvPr id="18" name="Rectangle 17">
+            <a:extLst>
+              <a:ext uri="{FF2B5EF4-FFF2-40B4-BE49-F238E27FC236}">
+                <a16:creationId xmlns:a16="http://schemas.microsoft.com/office/drawing/2014/main" id="{0D8D8114-0DD2-2D75-6601-909A6E3CBE6C}"/>
+              </a:ext>
+              <a:ext uri="{C183D7F6-B498-43B3-948B-1728B52AA6E4}">
+                <adec:decorative xmlns:adec="http://schemas.microsoft.com/office/drawing/2017/decorative" val="1"/>
+              </a:ext>
+            </a:extLst>
+          </p:cNvPr>
+          <p:cNvSpPr>
+            <a:spLocks noGrp="1" noRot="1" noChangeAspect="1" noMove="1" noResize="1" noEditPoints="1" noAdjustHandles="1" noChangeArrowheads="1" noChangeShapeType="1" noTextEdit="1"/>
+          </p:cNvSpPr>
+          <p:nvPr>
+            <p:extLst>
+              <p:ext uri="{386F3935-93C4-4BCD-93E2-E3B085C9AB24}">
+                <p16:designElem xmlns:p16="http://schemas.microsoft.com/office/powerpoint/2015/main" val="1"/>
+              </p:ext>
+            </p:extLst>
+          </p:nvPr>
+        </p:nvSpPr>
+        <p:spPr>
+          <a:xfrm>
+            <a:off x="0" y="0"/>
+            <a:ext cx="12192000" cy="6858000"/>
+          </a:xfrm>
+          <a:prstGeom prst="rect">
+            <a:avLst/>
+          </a:prstGeom>
+          <a:ln w="12700" cap="flat" cmpd="sng" algn="ctr">
+            <a:noFill/>
+            <a:prstDash val="solid"/>
+            <a:miter lim="800000"/>
+          </a:ln>
+          <a:effectLst/>
+          <a:extLst>
+            <a:ext uri="{91240B29-F687-4F45-9708-019B960494DF}">
+              <a14:hiddenLine xmlns:a14="http://schemas.microsoft.com/office/drawing/2010/main" w="12700" cap="flat" cmpd="sng" algn="ctr">
+                <a:solidFill>
+                  <a:schemeClr val="accent1">
+                    <a:shade val="50000"/>
+                  </a:schemeClr>
+                </a:solidFill>
+                <a:prstDash val="solid"/>
+                <a:miter lim="800000"/>
+              </a14:hiddenLine>
+            </a:ext>
+          </a:extLst>
+        </p:spPr>
+        <p:style>
+          <a:lnRef idx="2">
+            <a:schemeClr val="accent1">
+              <a:shade val="50000"/>
+            </a:schemeClr>
+          </a:lnRef>
+          <a:fillRef idx="1">
+            <a:schemeClr val="accent1"/>
+          </a:fillRef>
+          <a:effectRef idx="0">
+            <a:schemeClr val="accent1"/>
+          </a:effectRef>
+          <a:fontRef idx="minor">
+            <a:schemeClr val="lt1"/>
+          </a:fontRef>
+        </p:style>
+        <p:txBody>
+          <a:bodyPr rtlCol="0" anchor="ctr"/>
+          <a:lstStyle/>
+          <a:p>
+            <a:pPr algn="ctr"/>
+            <a:endParaRPr lang="en-US" sz="2000"/>
+          </a:p>
+        </p:txBody>
+      </p:sp>
+      <p:sp>
+        <p:nvSpPr>
+          <p:cNvPr id="20" name="Rectangle 19">
+            <a:extLst>
+              <a:ext uri="{FF2B5EF4-FFF2-40B4-BE49-F238E27FC236}">
+                <a16:creationId xmlns:a16="http://schemas.microsoft.com/office/drawing/2014/main" id="{F34B543B-BBAE-A619-B180-72D184562F0C}"/>
+              </a:ext>
+              <a:ext uri="{C183D7F6-B498-43B3-948B-1728B52AA6E4}">
+                <adec:decorative xmlns:adec="http://schemas.microsoft.com/office/drawing/2017/decorative" val="1"/>
+              </a:ext>
+            </a:extLst>
+          </p:cNvPr>
+          <p:cNvSpPr>
+            <a:spLocks noGrp="1" noRot="1" noChangeAspect="1" noMove="1" noResize="1" noEditPoints="1" noAdjustHandles="1" noChangeArrowheads="1" noChangeShapeType="1" noTextEdit="1"/>
+          </p:cNvSpPr>
+          <p:nvPr>
+            <p:extLst>
+              <p:ext uri="{386F3935-93C4-4BCD-93E2-E3B085C9AB24}">
+                <p16:designElem xmlns:p16="http://schemas.microsoft.com/office/powerpoint/2015/main" val="1"/>
+              </p:ext>
+            </p:extLst>
+          </p:nvPr>
+        </p:nvSpPr>
+        <p:spPr>
+          <a:xfrm flipH="1">
+            <a:off x="2" y="492"/>
+            <a:ext cx="12191998" cy="1575955"/>
+          </a:xfrm>
+          <a:prstGeom prst="rect">
+            <a:avLst/>
+          </a:prstGeom>
+          <a:gradFill>
+            <a:gsLst>
+              <a:gs pos="0">
+                <a:schemeClr val="accent1">
+                  <a:lumMod val="50000"/>
+                </a:schemeClr>
+              </a:gs>
+              <a:gs pos="100000">
+                <a:schemeClr val="accent1">
+                  <a:lumMod val="75000"/>
+                </a:schemeClr>
+              </a:gs>
+            </a:gsLst>
+            <a:lin ang="8400000" scaled="0"/>
+          </a:gradFill>
+          <a:ln>
+            <a:noFill/>
+          </a:ln>
+        </p:spPr>
+        <p:style>
+          <a:lnRef idx="2">
+            <a:schemeClr val="accent1">
+              <a:shade val="50000"/>
+            </a:schemeClr>
+          </a:lnRef>
+          <a:fillRef idx="1">
+            <a:schemeClr val="accent1"/>
+          </a:fillRef>
+          <a:effectRef idx="0">
+            <a:schemeClr val="accent1"/>
+          </a:effectRef>
+          <a:fontRef idx="minor">
+            <a:schemeClr val="lt1"/>
+          </a:fontRef>
+        </p:style>
+        <p:txBody>
+          <a:bodyPr rtlCol="0" anchor="ctr"/>
+          <a:lstStyle/>
+          <a:p>
+            <a:pPr algn="ctr"/>
+            <a:endParaRPr lang="en-US"/>
+          </a:p>
+        </p:txBody>
+      </p:sp>
+      <p:sp>
+        <p:nvSpPr>
+          <p:cNvPr id="22" name="Rectangle 21">
+            <a:extLst>
+              <a:ext uri="{FF2B5EF4-FFF2-40B4-BE49-F238E27FC236}">
+                <a16:creationId xmlns:a16="http://schemas.microsoft.com/office/drawing/2014/main" id="{B6484AC2-D4F2-432A-04E3-DE136140EFA9}"/>
+              </a:ext>
+              <a:ext uri="{C183D7F6-B498-43B3-948B-1728B52AA6E4}">
+                <adec:decorative xmlns:adec="http://schemas.microsoft.com/office/drawing/2017/decorative" val="1"/>
+              </a:ext>
+            </a:extLst>
+          </p:cNvPr>
+          <p:cNvSpPr>
+            <a:spLocks noGrp="1" noRot="1" noChangeAspect="1" noMove="1" noResize="1" noEditPoints="1" noAdjustHandles="1" noChangeArrowheads="1" noChangeShapeType="1" noTextEdit="1"/>
+          </p:cNvSpPr>
+          <p:nvPr>
+            <p:extLst>
+              <p:ext uri="{386F3935-93C4-4BCD-93E2-E3B085C9AB24}">
+                <p16:designElem xmlns:p16="http://schemas.microsoft.com/office/powerpoint/2015/main" val="1"/>
+              </p:ext>
+            </p:extLst>
+          </p:nvPr>
+        </p:nvSpPr>
+        <p:spPr>
+          <a:xfrm rot="10800000" flipH="1">
+            <a:off x="8128857" y="35"/>
+            <a:ext cx="4063143" cy="1576412"/>
+          </a:xfrm>
+          <a:prstGeom prst="rect">
+            <a:avLst/>
+          </a:prstGeom>
+          <a:gradFill>
+            <a:gsLst>
+              <a:gs pos="19000">
+                <a:schemeClr val="accent1">
+                  <a:lumMod val="50000"/>
+                  <a:alpha val="68000"/>
+                </a:schemeClr>
+              </a:gs>
+              <a:gs pos="100000">
+                <a:schemeClr val="accent1">
+                  <a:alpha val="79000"/>
+                </a:schemeClr>
+              </a:gs>
+            </a:gsLst>
+            <a:lin ang="19200000" scaled="0"/>
+          </a:gradFill>
+          <a:ln>
+            <a:noFill/>
+          </a:ln>
+        </p:spPr>
+        <p:style>
+          <a:lnRef idx="2">
+            <a:schemeClr val="accent1">
+              <a:shade val="50000"/>
+            </a:schemeClr>
+          </a:lnRef>
+          <a:fillRef idx="1">
+            <a:schemeClr val="accent1"/>
+          </a:fillRef>
+          <a:effectRef idx="0">
+            <a:schemeClr val="accent1"/>
+          </a:effectRef>
+          <a:fontRef idx="minor">
+            <a:schemeClr val="lt1"/>
+          </a:fontRef>
+        </p:style>
+        <p:txBody>
+          <a:bodyPr rtlCol="0" anchor="ctr"/>
+          <a:lstStyle/>
+          <a:p>
+            <a:pPr algn="ctr"/>
+            <a:endParaRPr lang="en-US"/>
+          </a:p>
+        </p:txBody>
+      </p:sp>
+      <p:sp>
+        <p:nvSpPr>
+          <p:cNvPr id="24" name="Rectangle 23">
+            <a:extLst>
+              <a:ext uri="{FF2B5EF4-FFF2-40B4-BE49-F238E27FC236}">
+                <a16:creationId xmlns:a16="http://schemas.microsoft.com/office/drawing/2014/main" id="{84941839-DAFA-5C2A-2C19-A142CE1EAB98}"/>
+              </a:ext>
+              <a:ext uri="{C183D7F6-B498-43B3-948B-1728B52AA6E4}">
+                <adec:decorative xmlns:adec="http://schemas.microsoft.com/office/drawing/2017/decorative" val="1"/>
+              </a:ext>
+            </a:extLst>
+          </p:cNvPr>
+          <p:cNvSpPr>
+            <a:spLocks noGrp="1" noRot="1" noChangeAspect="1" noMove="1" noResize="1" noEditPoints="1" noAdjustHandles="1" noChangeArrowheads="1" noChangeShapeType="1" noTextEdit="1"/>
+          </p:cNvSpPr>
+          <p:nvPr>
+            <p:extLst>
+              <p:ext uri="{386F3935-93C4-4BCD-93E2-E3B085C9AB24}">
+                <p16:designElem xmlns:p16="http://schemas.microsoft.com/office/powerpoint/2015/main" val="1"/>
+              </p:ext>
+            </p:extLst>
+          </p:nvPr>
+        </p:nvSpPr>
+        <p:spPr>
+          <a:xfrm rot="5400000">
+            <a:off x="5307778" y="-5307777"/>
+            <a:ext cx="1576446" cy="12192001"/>
+          </a:xfrm>
+          <a:prstGeom prst="rect">
+            <a:avLst/>
+          </a:prstGeom>
+          <a:gradFill>
+            <a:gsLst>
+              <a:gs pos="16000">
+                <a:srgbClr val="000000">
+                  <a:alpha val="0"/>
+                </a:srgbClr>
+              </a:gs>
+              <a:gs pos="99000">
+                <a:srgbClr val="000000">
+                  <a:alpha val="87000"/>
+                </a:srgbClr>
+              </a:gs>
+            </a:gsLst>
+            <a:lin ang="11400000" scaled="0"/>
+          </a:gradFill>
+          <a:ln>
+            <a:noFill/>
+          </a:ln>
+        </p:spPr>
+        <p:style>
+          <a:lnRef idx="2">
+            <a:schemeClr val="accent1">
+              <a:shade val="50000"/>
+            </a:schemeClr>
+          </a:lnRef>
+          <a:fillRef idx="1">
+            <a:schemeClr val="accent1"/>
+          </a:fillRef>
+          <a:effectRef idx="0">
+            <a:schemeClr val="accent1"/>
+          </a:effectRef>
+          <a:fontRef idx="minor">
+            <a:schemeClr val="lt1"/>
+          </a:fontRef>
+        </p:style>
+        <p:txBody>
+          <a:bodyPr rtlCol="0" anchor="ctr"/>
+          <a:lstStyle/>
+          <a:p>
+            <a:pPr algn="ctr"/>
+            <a:endParaRPr lang="en-US" dirty="0"/>
+          </a:p>
+        </p:txBody>
+      </p:sp>
+      <p:sp>
+        <p:nvSpPr>
+          <p:cNvPr id="26" name="Rectangle 25">
+            <a:extLst>
+              <a:ext uri="{FF2B5EF4-FFF2-40B4-BE49-F238E27FC236}">
+                <a16:creationId xmlns:a16="http://schemas.microsoft.com/office/drawing/2014/main" id="{2BA18926-AE65-F181-17DA-97DDF0D00EA2}"/>
+              </a:ext>
+              <a:ext uri="{C183D7F6-B498-43B3-948B-1728B52AA6E4}">
+                <adec:decorative xmlns:adec="http://schemas.microsoft.com/office/drawing/2017/decorative" val="1"/>
+              </a:ext>
+            </a:extLst>
+          </p:cNvPr>
+          <p:cNvSpPr>
+            <a:spLocks noGrp="1" noRot="1" noChangeAspect="1" noMove="1" noResize="1" noEditPoints="1" noAdjustHandles="1" noChangeArrowheads="1" noChangeShapeType="1" noTextEdit="1"/>
+          </p:cNvSpPr>
+          <p:nvPr>
+            <p:extLst>
+              <p:ext uri="{386F3935-93C4-4BCD-93E2-E3B085C9AB24}">
+                <p16:designElem xmlns:p16="http://schemas.microsoft.com/office/powerpoint/2015/main" val="1"/>
+              </p:ext>
+            </p:extLst>
+          </p:nvPr>
+        </p:nvSpPr>
+        <p:spPr>
+          <a:xfrm>
+            <a:off x="3825434" y="986"/>
+            <a:ext cx="4303422" cy="1575461"/>
+          </a:xfrm>
+          <a:prstGeom prst="rect">
+            <a:avLst/>
+          </a:prstGeom>
+          <a:gradFill>
+            <a:gsLst>
+              <a:gs pos="0">
+                <a:schemeClr val="accent1">
+                  <a:alpha val="17000"/>
+                </a:schemeClr>
+              </a:gs>
+              <a:gs pos="74000">
+                <a:schemeClr val="accent1">
+                  <a:lumMod val="50000"/>
+                  <a:alpha val="0"/>
+                </a:schemeClr>
+              </a:gs>
+            </a:gsLst>
+            <a:lin ang="14400000" scaled="0"/>
+          </a:gradFill>
+          <a:ln>
+            <a:noFill/>
+          </a:ln>
+        </p:spPr>
+        <p:style>
+          <a:lnRef idx="2">
+            <a:schemeClr val="accent1">
+              <a:shade val="50000"/>
+            </a:schemeClr>
+          </a:lnRef>
+          <a:fillRef idx="1">
+            <a:schemeClr val="accent1"/>
+          </a:fillRef>
+          <a:effectRef idx="0">
+            <a:schemeClr val="accent1"/>
+          </a:effectRef>
+          <a:fontRef idx="minor">
+            <a:schemeClr val="lt1"/>
+          </a:fontRef>
+        </p:style>
+        <p:txBody>
+          <a:bodyPr rtlCol="0" anchor="ctr"/>
+          <a:lstStyle/>
+          <a:p>
+            <a:pPr algn="ctr"/>
+            <a:endParaRPr lang="en-US"/>
+          </a:p>
+        </p:txBody>
+      </p:sp>
+      <p:sp>
+        <p:nvSpPr>
+          <p:cNvPr id="2" name="Title 1">
+            <a:extLst>
+              <a:ext uri="{FF2B5EF4-FFF2-40B4-BE49-F238E27FC236}">
+                <a16:creationId xmlns:a16="http://schemas.microsoft.com/office/drawing/2014/main" id="{038C0DA2-A3D4-0240-AF32-99CFBACE3BD3}"/>
+              </a:ext>
+            </a:extLst>
+          </p:cNvPr>
+          <p:cNvSpPr>
+            <a:spLocks noGrp="1"/>
+          </p:cNvSpPr>
+          <p:nvPr>
+            <p:ph type="title"/>
+          </p:nvPr>
+        </p:nvSpPr>
+        <p:spPr>
+          <a:xfrm>
+            <a:off x="699714" y="353160"/>
+            <a:ext cx="7091300" cy="898581"/>
+          </a:xfrm>
+        </p:spPr>
+        <p:txBody>
+          <a:bodyPr vert="horz" lIns="91440" tIns="45720" rIns="91440" bIns="45720" rtlCol="0" anchor="ctr">
+            <a:normAutofit/>
+          </a:bodyPr>
+          <a:lstStyle/>
+          <a:p>
+            <a:r>
+              <a:rPr lang="en-US" sz="4000" dirty="0">
+                <a:solidFill>
+                  <a:srgbClr val="FFFFFF"/>
+                </a:solidFill>
+              </a:rPr>
+              <a:t>Main Menu Code</a:t>
+            </a:r>
+          </a:p>
+        </p:txBody>
+      </p:sp>
+      <p:pic>
+        <p:nvPicPr>
+          <p:cNvPr id="7" name="Content Placeholder 6">
+            <a:extLst>
+              <a:ext uri="{FF2B5EF4-FFF2-40B4-BE49-F238E27FC236}">
+                <a16:creationId xmlns:a16="http://schemas.microsoft.com/office/drawing/2014/main" id="{499A299E-7CA4-9459-F65B-024699032BA5}"/>
+              </a:ext>
+            </a:extLst>
+          </p:cNvPr>
+          <p:cNvPicPr>
+            <a:picLocks noGrp="1" noChangeAspect="1"/>
+          </p:cNvPicPr>
+          <p:nvPr>
+            <p:ph idx="1"/>
+          </p:nvPr>
+        </p:nvPicPr>
+        <p:blipFill>
+          <a:blip r:embed="rId2"/>
+          <a:stretch>
+            <a:fillRect/>
+          </a:stretch>
+        </p:blipFill>
+        <p:spPr>
+          <a:xfrm>
+            <a:off x="1488028" y="1603915"/>
+            <a:ext cx="9215943" cy="5245438"/>
+          </a:xfrm>
+          <a:prstGeom prst="rect">
+            <a:avLst/>
+          </a:prstGeom>
+        </p:spPr>
+      </p:pic>
+    </p:spTree>
+    <p:extLst>
+      <p:ext uri="{BB962C8B-B14F-4D97-AF65-F5344CB8AC3E}">
+        <p14:creationId xmlns:p14="http://schemas.microsoft.com/office/powerpoint/2010/main" val="439909802"/>
       </p:ext>
     </p:extLst>
   </p:cSld>
@@ -7994,4 +9535,319 @@
     </a:ext>
   </a:extLst>
 </a:theme>
+</file>
+
+<file path=ppt/theme/theme2.xml><?xml version="1.0" encoding="utf-8"?>
+<a:theme xmlns:a="http://schemas.openxmlformats.org/drawingml/2006/main" name="Office Theme">
+  <a:themeElements>
+    <a:clrScheme name="Office">
+      <a:dk1>
+        <a:sysClr val="windowText" lastClr="000000"/>
+      </a:dk1>
+      <a:lt1>
+        <a:sysClr val="window" lastClr="FFFFFF"/>
+      </a:lt1>
+      <a:dk2>
+        <a:srgbClr val="0E2841"/>
+      </a:dk2>
+      <a:lt2>
+        <a:srgbClr val="E8E8E8"/>
+      </a:lt2>
+      <a:accent1>
+        <a:srgbClr val="156082"/>
+      </a:accent1>
+      <a:accent2>
+        <a:srgbClr val="E97132"/>
+      </a:accent2>
+      <a:accent3>
+        <a:srgbClr val="196B24"/>
+      </a:accent3>
+      <a:accent4>
+        <a:srgbClr val="0F9ED5"/>
+      </a:accent4>
+      <a:accent5>
+        <a:srgbClr val="A02B93"/>
+      </a:accent5>
+      <a:accent6>
+        <a:srgbClr val="4EA72E"/>
+      </a:accent6>
+      <a:hlink>
+        <a:srgbClr val="467886"/>
+      </a:hlink>
+      <a:folHlink>
+        <a:srgbClr val="96607D"/>
+      </a:folHlink>
+    </a:clrScheme>
+    <a:fontScheme name="Office">
+      <a:majorFont>
+        <a:latin typeface="Aptos Display" panose="02110004020202020204"/>
+        <a:ea typeface=""/>
+        <a:cs typeface=""/>
+        <a:font script="Jpan" typeface="游ゴシック Light"/>
+        <a:font script="Hang" typeface="맑은 고딕"/>
+        <a:font script="Hans" typeface="等线 Light"/>
+        <a:font script="Hant" typeface="新細明體"/>
+        <a:font script="Arab" typeface="Times New Roman"/>
+        <a:font script="Hebr" typeface="Times New Roman"/>
+        <a:font script="Thai" typeface="Angsana New"/>
+        <a:font script="Ethi" typeface="Nyala"/>
+        <a:font script="Beng" typeface="Vrinda"/>
+        <a:font script="Gujr" typeface="Shruti"/>
+        <a:font script="Khmr" typeface="MoolBoran"/>
+        <a:font script="Knda" typeface="Tunga"/>
+        <a:font script="Guru" typeface="Raavi"/>
+        <a:font script="Cans" typeface="Euphemia"/>
+        <a:font script="Cher" typeface="Plantagenet Cherokee"/>
+        <a:font script="Yiii" typeface="Microsoft Yi Baiti"/>
+        <a:font script="Tibt" typeface="Microsoft Himalaya"/>
+        <a:font script="Thaa" typeface="MV Boli"/>
+        <a:font script="Deva" typeface="Mangal"/>
+        <a:font script="Telu" typeface="Gautami"/>
+        <a:font script="Taml" typeface="Latha"/>
+        <a:font script="Syrc" typeface="Estrangelo Edessa"/>
+        <a:font script="Orya" typeface="Kalinga"/>
+        <a:font script="Mlym" typeface="Kartika"/>
+        <a:font script="Laoo" typeface="DokChampa"/>
+        <a:font script="Sinh" typeface="Iskoola Pota"/>
+        <a:font script="Mong" typeface="Mongolian Baiti"/>
+        <a:font script="Viet" typeface="Times New Roman"/>
+        <a:font script="Uigh" typeface="Microsoft Uighur"/>
+        <a:font script="Geor" typeface="Sylfaen"/>
+        <a:font script="Armn" typeface="Arial"/>
+        <a:font script="Bugi" typeface="Leelawadee UI"/>
+        <a:font script="Bopo" typeface="Microsoft JhengHei"/>
+        <a:font script="Java" typeface="Javanese Text"/>
+        <a:font script="Lisu" typeface="Segoe UI"/>
+        <a:font script="Mymr" typeface="Myanmar Text"/>
+        <a:font script="Nkoo" typeface="Ebrima"/>
+        <a:font script="Olck" typeface="Nirmala UI"/>
+        <a:font script="Osma" typeface="Ebrima"/>
+        <a:font script="Phag" typeface="Phagspa"/>
+        <a:font script="Syrn" typeface="Estrangelo Edessa"/>
+        <a:font script="Syrj" typeface="Estrangelo Edessa"/>
+        <a:font script="Syre" typeface="Estrangelo Edessa"/>
+        <a:font script="Sora" typeface="Nirmala UI"/>
+        <a:font script="Tale" typeface="Microsoft Tai Le"/>
+        <a:font script="Talu" typeface="Microsoft New Tai Lue"/>
+        <a:font script="Tfng" typeface="Ebrima"/>
+      </a:majorFont>
+      <a:minorFont>
+        <a:latin typeface="Aptos" panose="02110004020202020204"/>
+        <a:ea typeface=""/>
+        <a:cs typeface=""/>
+        <a:font script="Jpan" typeface="游ゴシック"/>
+        <a:font script="Hang" typeface="맑은 고딕"/>
+        <a:font script="Hans" typeface="等线"/>
+        <a:font script="Hant" typeface="新細明體"/>
+        <a:font script="Arab" typeface="Arial"/>
+        <a:font script="Hebr" typeface="Arial"/>
+        <a:font script="Thai" typeface="Cordia New"/>
+        <a:font script="Ethi" typeface="Nyala"/>
+        <a:font script="Beng" typeface="Vrinda"/>
+        <a:font script="Gujr" typeface="Shruti"/>
+        <a:font script="Khmr" typeface="DaunPenh"/>
+        <a:font script="Knda" typeface="Tunga"/>
+        <a:font script="Guru" typeface="Raavi"/>
+        <a:font script="Cans" typeface="Euphemia"/>
+        <a:font script="Cher" typeface="Plantagenet Cherokee"/>
+        <a:font script="Yiii" typeface="Microsoft Yi Baiti"/>
+        <a:font script="Tibt" typeface="Microsoft Himalaya"/>
+        <a:font script="Thaa" typeface="MV Boli"/>
+        <a:font script="Deva" typeface="Mangal"/>
+        <a:font script="Telu" typeface="Gautami"/>
+        <a:font script="Taml" typeface="Latha"/>
+        <a:font script="Syrc" typeface="Estrangelo Edessa"/>
+        <a:font script="Orya" typeface="Kalinga"/>
+        <a:font script="Mlym" typeface="Kartika"/>
+        <a:font script="Laoo" typeface="DokChampa"/>
+        <a:font script="Sinh" typeface="Iskoola Pota"/>
+        <a:font script="Mong" typeface="Mongolian Baiti"/>
+        <a:font script="Viet" typeface="Arial"/>
+        <a:font script="Uigh" typeface="Microsoft Uighur"/>
+        <a:font script="Geor" typeface="Sylfaen"/>
+        <a:font script="Armn" typeface="Arial"/>
+        <a:font script="Bugi" typeface="Leelawadee UI"/>
+        <a:font script="Bopo" typeface="Microsoft JhengHei"/>
+        <a:font script="Java" typeface="Javanese Text"/>
+        <a:font script="Lisu" typeface="Segoe UI"/>
+        <a:font script="Mymr" typeface="Myanmar Text"/>
+        <a:font script="Nkoo" typeface="Ebrima"/>
+        <a:font script="Olck" typeface="Nirmala UI"/>
+        <a:font script="Osma" typeface="Ebrima"/>
+        <a:font script="Phag" typeface="Phagspa"/>
+        <a:font script="Syrn" typeface="Estrangelo Edessa"/>
+        <a:font script="Syrj" typeface="Estrangelo Edessa"/>
+        <a:font script="Syre" typeface="Estrangelo Edessa"/>
+        <a:font script="Sora" typeface="Nirmala UI"/>
+        <a:font script="Tale" typeface="Microsoft Tai Le"/>
+        <a:font script="Talu" typeface="Microsoft New Tai Lue"/>
+        <a:font script="Tfng" typeface="Ebrima"/>
+      </a:minorFont>
+    </a:fontScheme>
+    <a:fmtScheme name="Office">
+      <a:fillStyleLst>
+        <a:solidFill>
+          <a:schemeClr val="phClr"/>
+        </a:solidFill>
+        <a:gradFill rotWithShape="1">
+          <a:gsLst>
+            <a:gs pos="0">
+              <a:schemeClr val="phClr">
+                <a:lumMod val="110000"/>
+                <a:satMod val="105000"/>
+                <a:tint val="67000"/>
+              </a:schemeClr>
+            </a:gs>
+            <a:gs pos="50000">
+              <a:schemeClr val="phClr">
+                <a:lumMod val="105000"/>
+                <a:satMod val="103000"/>
+                <a:tint val="73000"/>
+              </a:schemeClr>
+            </a:gs>
+            <a:gs pos="100000">
+              <a:schemeClr val="phClr">
+                <a:lumMod val="105000"/>
+                <a:satMod val="109000"/>
+                <a:tint val="81000"/>
+              </a:schemeClr>
+            </a:gs>
+          </a:gsLst>
+          <a:lin ang="5400000" scaled="0"/>
+        </a:gradFill>
+        <a:gradFill rotWithShape="1">
+          <a:gsLst>
+            <a:gs pos="0">
+              <a:schemeClr val="phClr">
+                <a:satMod val="103000"/>
+                <a:lumMod val="102000"/>
+                <a:tint val="94000"/>
+              </a:schemeClr>
+            </a:gs>
+            <a:gs pos="50000">
+              <a:schemeClr val="phClr">
+                <a:satMod val="110000"/>
+                <a:lumMod val="100000"/>
+                <a:shade val="100000"/>
+              </a:schemeClr>
+            </a:gs>
+            <a:gs pos="100000">
+              <a:schemeClr val="phClr">
+                <a:lumMod val="99000"/>
+                <a:satMod val="120000"/>
+                <a:shade val="78000"/>
+              </a:schemeClr>
+            </a:gs>
+          </a:gsLst>
+          <a:lin ang="5400000" scaled="0"/>
+        </a:gradFill>
+      </a:fillStyleLst>
+      <a:lnStyleLst>
+        <a:ln w="12700" cap="flat" cmpd="sng" algn="ctr">
+          <a:solidFill>
+            <a:schemeClr val="phClr"/>
+          </a:solidFill>
+          <a:prstDash val="solid"/>
+          <a:miter lim="800000"/>
+        </a:ln>
+        <a:ln w="19050" cap="flat" cmpd="sng" algn="ctr">
+          <a:solidFill>
+            <a:schemeClr val="phClr"/>
+          </a:solidFill>
+          <a:prstDash val="solid"/>
+          <a:miter lim="800000"/>
+        </a:ln>
+        <a:ln w="25400" cap="flat" cmpd="sng" algn="ctr">
+          <a:solidFill>
+            <a:schemeClr val="phClr"/>
+          </a:solidFill>
+          <a:prstDash val="solid"/>
+          <a:miter lim="800000"/>
+        </a:ln>
+      </a:lnStyleLst>
+      <a:effectStyleLst>
+        <a:effectStyle>
+          <a:effectLst/>
+        </a:effectStyle>
+        <a:effectStyle>
+          <a:effectLst/>
+        </a:effectStyle>
+        <a:effectStyle>
+          <a:effectLst>
+            <a:outerShdw blurRad="57150" dist="19050" dir="5400000" algn="ctr" rotWithShape="0">
+              <a:srgbClr val="000000">
+                <a:alpha val="63000"/>
+              </a:srgbClr>
+            </a:outerShdw>
+          </a:effectLst>
+        </a:effectStyle>
+      </a:effectStyleLst>
+      <a:bgFillStyleLst>
+        <a:solidFill>
+          <a:schemeClr val="phClr"/>
+        </a:solidFill>
+        <a:solidFill>
+          <a:schemeClr val="phClr">
+            <a:tint val="95000"/>
+            <a:satMod val="170000"/>
+          </a:schemeClr>
+        </a:solidFill>
+        <a:gradFill rotWithShape="1">
+          <a:gsLst>
+            <a:gs pos="0">
+              <a:schemeClr val="phClr">
+                <a:tint val="93000"/>
+                <a:satMod val="150000"/>
+                <a:shade val="98000"/>
+                <a:lumMod val="102000"/>
+              </a:schemeClr>
+            </a:gs>
+            <a:gs pos="50000">
+              <a:schemeClr val="phClr">
+                <a:tint val="98000"/>
+                <a:satMod val="130000"/>
+                <a:shade val="90000"/>
+                <a:lumMod val="103000"/>
+              </a:schemeClr>
+            </a:gs>
+            <a:gs pos="100000">
+              <a:schemeClr val="phClr">
+                <a:shade val="63000"/>
+                <a:satMod val="120000"/>
+              </a:schemeClr>
+            </a:gs>
+          </a:gsLst>
+          <a:lin ang="5400000" scaled="0"/>
+        </a:gradFill>
+      </a:bgFillStyleLst>
+    </a:fmtScheme>
+  </a:themeElements>
+  <a:objectDefaults>
+    <a:lnDef>
+      <a:spPr/>
+      <a:bodyPr/>
+      <a:lstStyle/>
+      <a:style>
+        <a:lnRef idx="2">
+          <a:schemeClr val="accent1"/>
+        </a:lnRef>
+        <a:fillRef idx="0">
+          <a:schemeClr val="accent1"/>
+        </a:fillRef>
+        <a:effectRef idx="1">
+          <a:schemeClr val="accent1"/>
+        </a:effectRef>
+        <a:fontRef idx="minor">
+          <a:schemeClr val="tx1"/>
+        </a:fontRef>
+      </a:style>
+    </a:lnDef>
+  </a:objectDefaults>
+  <a:extraClrSchemeLst/>
+  <a:extLst>
+    <a:ext uri="{05A4C25C-085E-4340-85A3-A5531E510DB2}">
+      <thm15:themeFamily xmlns:thm15="http://schemas.microsoft.com/office/thememl/2012/main" name="Office Theme" id="{2E142A2C-CD16-42D6-873A-C26D2A0506FA}" vid="{1BDDFF52-6CD6-40A5-AB3C-68EB2F1E4D0A}"/>
+    </a:ext>
+  </a:extLst>
+</a:theme>
 </file>
</xml_diff>